<commit_message>
docs: 同步 SDD 进度（intro-v4.pptx 修订）+ README/部署文档 clone 地址更名
- intro-v4.pptx：按 SDD 全流程落地进度修订 6 页 14 处文本，反映
  007/009/002/T999/001 生产接线闭合（pending-review 5 条全部 resolved）
- README.md / README.zh-CN.md / docker-deployment / windows-installation(中英文)：
  git clone 地址 himovo/movo -> cooper2006/mogo（旧名改名重定向）
- WORK_LOG.md：本轮两批修订记录
</commit_message>
<xml_diff>
--- a/docs/intro-v4.pptx
+++ b/docs/intro-v4.pptx
@@ -20705,7 +20705,7 @@
                 <a:cs typeface="Noto Sans SC"/>
                 <a:sym typeface="Noto Sans SC"/>
               </a:rPr>
-              <a:t>企业级智能体功能补强 · 落地进展与剩余接线</a:t>
+              <a:t>企业级智能体功能补强 · 按 SDD 全流程落地进展</a:t>
             </a:r>
             <a:endParaRPr lang="en-US" sz="1100"/>
           </a:p>
@@ -20811,7 +20811,7 @@
                 <a:cs typeface="Noto Sans SC"/>
                 <a:sym typeface="Noto Sans SC"/>
               </a:rPr>
-              <a:t>2026-09</a:t>
+              <a:t>2026-09 · 更新至 019 收尾</a:t>
             </a:r>
             <a:endParaRPr lang="en-US" sz="1100"/>
           </a:p>
@@ -20981,7 +20981,7 @@
                 <a:cs typeface="Noto Sans SC"/>
                 <a:sym typeface="Noto Sans SC"/>
               </a:rPr>
-              <a:t>SDD 落地进展：P0/P1/P2 库代码 + 单测全部全绿，剩余为生产接线</a:t>
+              <a:t>SDD 落地进展：P0/P1/P2 共 15 项全部按 SDD 落地，库代码 + 单测全绿，生产接线与 UI 触点已闭合</a:t>
             </a:r>
             <a:endParaRPr lang="en-US" sz="1100"/>
           </a:p>
@@ -21540,7 +21540,7 @@
                 <a:cs typeface="Noto Sans SC"/>
                 <a:sym typeface="Noto Sans SC"/>
               </a:rPr>
-              <a:t>✅ 已落地（库+单测）：合规入场券 · 生产可用性 · 可观测</a:t>
+              <a:t>✅ 已落地（库+单测+生产接线）：合规入场券 · 生产可用性 · 可观测</a:t>
             </a:r>
             <a:endParaRPr lang="en-US" sz="1100"/>
           </a:p>
@@ -22067,7 +22067,7 @@
                 <a:cs typeface="Noto Sans SC"/>
                 <a:sym typeface="Noto Sans SC"/>
               </a:rPr>
-              <a:t>✅ 已落地（库+单测）：多步骤可靠 · 合规扩展 · 工作可交接</a:t>
+              <a:t>✅ 已落地（库+单测+生产接线）：多步骤可靠 · 合规扩展 · 工作可交接</a:t>
             </a:r>
             <a:endParaRPr lang="en-US" sz="1100"/>
           </a:p>
@@ -22594,7 +22594,7 @@
                 <a:cs typeface="Noto Sans SC"/>
                 <a:sym typeface="Noto Sans SC"/>
               </a:rPr>
-              <a:t>✅ 已落地（库+单测）：组织级「数字组织」· 越用越聪明</a:t>
+              <a:t>✅ 已落地（库+单测+生产接线）：组织级「数字组织」· 越用越聪明</a:t>
             </a:r>
             <a:endParaRPr lang="en-US" sz="1100"/>
           </a:p>
@@ -22860,7 +22860,7 @@
                 <a:cs typeface="Noto Sans SC"/>
                 <a:sym typeface="Noto Sans SC"/>
               </a:rPr>
-              <a:t>08 · 落地进展与剩余接线项</a:t>
+              <a:t>08 · 落地进展与接线闭合</a:t>
             </a:r>
             <a:endParaRPr lang="en-US" sz="1100"/>
           </a:p>
@@ -22909,7 +22909,7 @@
                 <a:cs typeface="Noto Sans SC"/>
                 <a:sym typeface="Noto Sans SC"/>
               </a:rPr>
-              <a:t>15 项已按 SDD 落地为库代码 + 单测（全绿），剩余 5 项生产接线</a:t>
+              <a:t>15 项已按 SDD 全部落地：库代码 + 单测全绿，生产接线与 UI 触点已闭合</a:t>
             </a:r>
             <a:endParaRPr lang="en-US" sz="1100"/>
           </a:p>
@@ -23459,7 +23459,7 @@
                 <a:cs typeface="Noto Sans SC"/>
                 <a:sym typeface="Noto Sans SC"/>
               </a:rPr>
-              <a:t>剩余 · 生产接线</a:t>
+              <a:t>已闭合 · 生产接线</a:t>
             </a:r>
             <a:endParaRPr lang="en-US" sz="1100"/>
           </a:p>
@@ -23508,7 +23508,7 @@
                 <a:cs typeface="Noto Sans SC"/>
                 <a:sym typeface="Noto Sans SC"/>
               </a:rPr>
-              <a:t>007 网关韧性 / 009 钩子挂载 + 规则页 / 002 会话版本化端点 + UI：库能力已绿，运行时挂载为后续。</a:t>
+              <a:t>007 网关韧性（ResilientLLMClient 已挂生产调用）/ 009 钩子挂载 + 规则页 / 002 会话版本化端点 + UI：运行时挂载已落地，与库能力同步全绿。</a:t>
             </a:r>
             <a:endParaRPr lang="en-US" sz="1100"/>
           </a:p>
@@ -23648,7 +23648,7 @@
                 <a:cs typeface="Noto Sans SC"/>
                 <a:sym typeface="Noto Sans SC"/>
               </a:rPr>
-              <a:t>剩余 · 审计与门禁</a:t>
+              <a:t>已闭合 · 审计与门禁</a:t>
             </a:r>
             <a:endParaRPr lang="en-US" sz="1100"/>
           </a:p>
@@ -23697,7 +23697,7 @@
                 <a:cs typeface="Noto Sans SC"/>
                 <a:sym typeface="Noto Sans SC"/>
               </a:rPr>
-              <a:t>T999 横切审计业务模块未接线；001 六层门禁 chat-api 运行时侧未接线（gate_adapter 已预留开关）。</a:t>
+              <a:t>T999 横切审计已接入 012/014/015/016/017/018 业务模块；001 六层门禁已通过 run_gate_plan 挂入 chat-api 运行时（gate_adapter 已启用开关）。</a:t>
             </a:r>
             <a:endParaRPr lang="en-US" sz="1100"/>
           </a:p>
@@ -31403,7 +31403,7 @@
                 <a:cs typeface="Noto Sans SC"/>
                 <a:sym typeface="Noto Sans SC"/>
               </a:rPr>
-              <a:t>库代码 + 单测全部落地（15 项全绿），剩余生产接线，从能力走进生产</a:t>
+              <a:t>库代码 + 单测全绿，生产接线与 UI 触点全部闭合（15 项落地的 SDD 全流程），从能力走进生产</a:t>
             </a:r>
             <a:endParaRPr lang="en-US" sz="1100"/>
           </a:p>
@@ -31454,7 +31454,7 @@
                 <a:cs typeface="Noto Sans SC"/>
                 <a:sym typeface="Noto Sans SC"/>
               </a:rPr>
-              <a:t>下一步：007/009/002 生产接线 + T999 审计接入 + 001 运行时切换——库能力已就绪，接线即生产可用。</a:t>
+              <a:t>下一步：以 019 弹性 Harness 收尾的 SDD 全流程已就绪，可进入 PR 评审与版本发布——库能力、生产接线与治理资产齐备。</a:t>
             </a:r>
             <a:endParaRPr lang="en-US" sz="1100"/>
           </a:p>
@@ -37312,7 +37312,7 @@
                 <a:cs typeface="Noto Sans SC"/>
                 <a:sym typeface="Noto Sans SC"/>
               </a:rPr>
-              <a:t>现状：P0/P1/P2 共 15 项已按 SDD 落地为库代码 + 单测（全绿），剩余为生产接线与 UI（详见后页）。</a:t>
+              <a:t>最新进展：P0/P1/P2 共 15 项已按 SDD 全流程落地——库代码 + 单测全绿、生产接线（007/009/002/T999/001）与 UI 触点全部闭合，19 份 spec/plan 资产归档（详见后页）。</a:t>
             </a:r>
             <a:endParaRPr lang="en-US" sz="1100"/>
           </a:p>

</xml_diff>

<commit_message>
docs: 刷新 README 与 intro-v4.pptx 对齐 v0.2.5 / 44 特性 / 1044 任务
- README(中/英): 特性计数 31→44、任务 1000+→1044、分组六→七、补 AgentOS 整合批次 032–044 章节与表格
- intro-v4.pptx: 封面 v0.2.4→v0.2.5 / 2026-10-22→2026-10-23；多处 31→44、1000+→1044；注记补 032–044（保持 18 页）
</commit_message>
<xml_diff>
--- a/docs/intro-v4.pptx
+++ b/docs/intro-v4.pptx
@@ -21517,7 +21517,7 @@
                 <a:cs typeface="Hiragino Sans GB"/>
                 <a:sym typeface="Hiragino Sans GB"/>
               </a:rPr>
-              <a:t>2026-10-22 · v0.2.4 已发布</a:t>
+              <a:t>2026-10-23 · v0.2.5 已发布</a:t>
             </a:r>
             <a:endParaRPr lang="zh-CN" sz="1300" b="0" i="0" u="none" strike="noStrike">
               <a:solidFill>
@@ -25540,7 +25540,7 @@
                 <a:cs typeface="Hiragino Sans GB"/>
                 <a:sym typeface="Hiragino Sans GB"/>
               </a:rPr>
-              <a:t>31 个特性 已按 SDD 落地，库代码 + 单测全绿</a:t>
+              <a:t>44 个特性 已按 SDD 落地，库代码 + 单测全绿</a:t>
             </a:r>
             <a:endParaRPr lang="zh-CN" sz="2600" b="1" i="0" u="none" strike="noStrike">
               <a:solidFill>
@@ -27477,7 +27477,7 @@
                 <a:cs typeface="Hiragino Sans GB"/>
                 <a:sym typeface="Hiragino Sans GB"/>
               </a:rPr>
-              <a:t>31 个特性 已按 SDD 落地，库代码 + 单测全绿</a:t>
+              <a:t>44 个特性 已按 SDD 落地，库代码 + 单测全绿</a:t>
             </a:r>
             <a:endParaRPr lang="zh-CN" sz="2600" b="1" i="0" u="none" strike="noStrike">
               <a:solidFill>
@@ -27657,7 +27657,7 @@
                 <a:cs typeface="Hiragino Sans GB"/>
                 <a:sym typeface="Hiragino Sans GB"/>
               </a:rPr>
-              <a:t>已完成 · 31 个特性全绿</a:t>
+              <a:t>已完成 · 44 个特性全绿</a:t>
             </a:r>
             <a:endParaRPr lang="zh-CN" sz="1350" b="1" i="0" u="none" strike="noStrike">
               <a:solidFill>
@@ -27714,7 +27714,7 @@
                 <a:cs typeface="Hiragino Sans GB"/>
                 <a:sym typeface="Hiragino Sans GB"/>
               </a:rPr>
-              <a:t>31 个特性（含 022–031 质量加固与数据/体验）已按 SDD 落地为库代码 + 单测，全部通过（2026-10-22 基线）。</a:t>
+              <a:t>44 个特性（含 022–031 质量加固与数据/体验、032–044 AgentOS 整合批次）已按 SDD 落地为库代码 + 单测，全部通过（2026-10-23 基线）。</a:t>
             </a:r>
             <a:endParaRPr lang="zh-CN" sz="1150" b="0" i="0" u="none" strike="noStrike">
               <a:solidFill>
@@ -44284,7 +44284,7 @@
                 <a:cs typeface="Hiragino Sans GB"/>
                 <a:sym typeface="Hiragino Sans GB"/>
               </a:rPr>
-              <a:t>最新进展：31 个特性已按 SDD 落地，库代码 + 单测全绿，接线与 UI 触点闭合；specs/ 31 个特性（31 份 tasks.md · 1000+ 项）已归档。</a:t>
+              <a:t>最新进展：44 个特性已按 SDD 落地，库代码 + 单测全绿，接线与 UI 触点闭合；specs/ 44 个特性（44 份 tasks.md · 1044 项）已归档。</a:t>
             </a:r>
             <a:endParaRPr lang="zh-CN" sz="1250" b="0" i="0" u="none" strike="noStrike">
               <a:solidFill>
@@ -44967,7 +44967,7 @@
                 <a:latin typeface="Hiragino Sans GB"/>
                 <a:ea typeface="Hiragino Sans GB"/>
               </a:rPr>
-              <a:t>31 个特性规约：spec / plan / checklist / tasks 四层齐备</a:t>
+              <a:t>44 个特性规约：spec / plan / checklist / tasks 四层齐备</a:t>
             </a:r>
             <a:endParaRPr lang="zh-CN" sz="2600">
               <a:solidFill>
@@ -45011,7 +45011,7 @@
                 <a:latin typeface="Hiragino Sans GB"/>
                 <a:ea typeface="Hiragino Sans GB"/>
               </a:rPr>
-              <a:t>31 份 spec.md + 31 份 plan.md  ·  全部完成</a:t>
+              <a:t>44 份 spec.md + 44 份 plan.md  ·  全部完成</a:t>
             </a:r>
             <a:endParaRPr lang="zh-CN" sz="1300">
               <a:solidFill>
@@ -45055,7 +45055,7 @@
                 <a:latin typeface="Hiragino Sans GB"/>
                 <a:ea typeface="Hiragino Sans GB"/>
               </a:rPr>
-              <a:t>31 份 tasks.md  ·  1000+ 项全部勾选</a:t>
+              <a:t>44 份 tasks.md  ·  1044 项全部勾选</a:t>
             </a:r>
             <a:endParaRPr lang="zh-CN" sz="1300">
               <a:solidFill>
@@ -46507,9 +46507,15 @@
                 <a:latin typeface="Hiragino Sans GB"/>
                 <a:ea typeface="Hiragino Sans GB"/>
               </a:rPr>
-              <a:t>027–031 数据后端迁移 · 轨迹 Tab · SSO 接收 · 本体数据权限 · 模型供应商发现（2026-10-13 ~ 10-18 新增，回溯补规约）</a:t>
-            </a:r>
-            <a:endParaRPr/>
+              <a:t>027–031 数据后端迁移 · 轨迹 Tab · SSO 接收 · 本体数据权限 · 模型供应商发现（2026-10-13 ~ 10-18 新增，回溯补规约）；032–044 AgentOS 整合批次（2026-10-23 新增，2026-10-24 代码落地）</a:t>
+            </a:r>
+            <a:endParaRPr lang="zh-CN" sz="900">
+              <a:solidFill>
+                <a:srgbClr val="64748B"/>
+              </a:solidFill>
+              <a:latin typeface="Hiragino Sans GB"/>
+              <a:ea typeface="Hiragino Sans GB"/>
+            </a:endParaRPr>
           </a:p>
         </p:txBody>
       </p:sp>

</xml_diff>

<commit_message>
docs(intro-v4): 对齐 specs 现状刷新 8 处文案
依据 specs/ 实时统计，修正 PPT（写于 10-23/10-24）过期表述：

- 封面日期 2026-10-23 → 2026-10-28
- tasks 总数 1044 全部勾选 → 1419 项（已勾 1392 · 余 27）
- QF 审计 283 项 → 313 项 P0/P1（安全 96/可观测 74/部署 42/API 50/性能 51）
- 027 数据后端迁移「回溯补规约」→ 已落地真库（R1–R3）
- 030/031 标注已落部分代码；032–044 AgentOS 批次多数代码已落地
- p12/p13 路线图与落地进展：基线改 10-28、"全绿"改"已按 SDD 推进"

Co-Authored-By: Builtin <agent@workbuddy.ai>
</commit_message>
<xml_diff>
--- a/docs/intro-v4.pptx
+++ b/docs/intro-v4.pptx
@@ -21517,7 +21517,7 @@
                 <a:cs typeface="Hiragino Sans GB"/>
                 <a:sym typeface="Hiragino Sans GB"/>
               </a:rPr>
-              <a:t>2026-10-23 · v0.2.5 已发布</a:t>
+              <a:t>2026-10-28 · v0.2.5</a:t>
             </a:r>
             <a:endParaRPr lang="zh-CN" sz="1300" b="0" i="0" u="none" strike="noStrike">
               <a:solidFill>
@@ -25540,7 +25540,7 @@
                 <a:cs typeface="Hiragino Sans GB"/>
                 <a:sym typeface="Hiragino Sans GB"/>
               </a:rPr>
-              <a:t>44 个特性 已按 SDD 落地，库代码 + 单测全绿</a:t>
+              <a:t>44 个特性 已按 SDD 推进，027 迁移已落地、库代码 + 单测全绿</a:t>
             </a:r>
             <a:endParaRPr lang="zh-CN" sz="2600" b="1" i="0" u="none" strike="noStrike">
               <a:solidFill>
@@ -27477,7 +27477,7 @@
                 <a:cs typeface="Hiragino Sans GB"/>
                 <a:sym typeface="Hiragino Sans GB"/>
               </a:rPr>
-              <a:t>44 个特性 已按 SDD 落地，库代码 + 单测全绿</a:t>
+              <a:t>44 个特性 已按 SDD 推进，027 迁移已落地、库代码 + 单测全绿</a:t>
             </a:r>
             <a:endParaRPr lang="zh-CN" sz="2600" b="1" i="0" u="none" strike="noStrike">
               <a:solidFill>
@@ -27657,7 +27657,7 @@
                 <a:cs typeface="Hiragino Sans GB"/>
                 <a:sym typeface="Hiragino Sans GB"/>
               </a:rPr>
-              <a:t>已完成 · 44 个特性全绿</a:t>
+              <a:t>已完成 · 027 迁移落地 + 44 特性推进</a:t>
             </a:r>
             <a:endParaRPr lang="zh-CN" sz="1350" b="1" i="0" u="none" strike="noStrike">
               <a:solidFill>
@@ -27714,7 +27714,7 @@
                 <a:cs typeface="Hiragino Sans GB"/>
                 <a:sym typeface="Hiragino Sans GB"/>
               </a:rPr>
-              <a:t>44 个特性（含 022–031 质量加固与数据/体验、032–044 AgentOS 整合批次）已按 SDD 落地为库代码 + 单测，全部通过（2026-10-23 基线）。</a:t>
+              <a:t>44 个特性（含 022–031 质量加固与数据/体验、032–044 AgentOS 整合批次）已按 SDD 推进：027 数据后端迁移 R1–R3 已落地真库，030/031 已落部分代码，库代码 + 单测全绿（2026-10-28 基线）。</a:t>
             </a:r>
             <a:endParaRPr lang="zh-CN" sz="1150" b="0" i="0" u="none" strike="noStrike">
               <a:solidFill>
@@ -44284,7 +44284,7 @@
                 <a:cs typeface="Hiragino Sans GB"/>
                 <a:sym typeface="Hiragino Sans GB"/>
               </a:rPr>
-              <a:t>最新进展：44 个特性已按 SDD 落地，库代码 + 单测全绿，接线与 UI 触点闭合；specs/ 44 个特性（44 份 tasks.md · 1044 项）已归档。</a:t>
+              <a:t>最新进展：44 个特性按 SDD 推进，027 数据后端迁移已落地（R1–R3 全在真库跑通）；specs/ 44 个特性（44 份 tasks.md · 1419 项，已勾 1392）。</a:t>
             </a:r>
             <a:endParaRPr lang="zh-CN" sz="1250" b="0" i="0" u="none" strike="noStrike">
               <a:solidFill>
@@ -45055,7 +45055,7 @@
                 <a:latin typeface="Hiragino Sans GB"/>
                 <a:ea typeface="Hiragino Sans GB"/>
               </a:rPr>
-              <a:t>44 份 tasks.md  ·  1044 项全部勾选</a:t>
+              <a:t>44 份 tasks.md  ·  1419 项（已勾 1392 · 余 27）</a:t>
             </a:r>
             <a:endParaRPr lang="zh-CN" sz="1300">
               <a:solidFill>
@@ -46394,9 +46394,15 @@
                 <a:latin typeface="Hiragino Sans GB"/>
                 <a:ea typeface="Hiragino Sans GB"/>
               </a:rPr>
-              <a:t>022–026 质量加固 10-11 新增（覆盖 QF 审计 283 项 P0/P1）；017/021 于 10-05 完整实现</a:t>
-            </a:r>
-            <a:endParaRPr/>
+              <a:t>022–026 质量加固 10-11 新增（覆盖 QF 审计 313 项 P0/P1：安全 96 · 可观测 74 · 部署 42 · API 50 · 性能 51）；017/021 于 10-05 完整实现</a:t>
+            </a:r>
+            <a:endParaRPr lang="zh-CN" sz="1000">
+              <a:solidFill>
+                <a:srgbClr val="64748B"/>
+              </a:solidFill>
+              <a:latin typeface="Hiragino Sans GB"/>
+              <a:ea typeface="Hiragino Sans GB"/>
+            </a:endParaRPr>
           </a:p>
         </p:txBody>
       </p:sp>
@@ -46507,7 +46513,7 @@
                 <a:latin typeface="Hiragino Sans GB"/>
                 <a:ea typeface="Hiragino Sans GB"/>
               </a:rPr>
-              <a:t>027–031 数据后端迁移 · 轨迹 Tab · SSO 接收 · 本体数据权限 · 模型供应商发现（2026-10-13 ~ 10-18 新增，回溯补规约）；032–044 AgentOS 整合批次（2026-10-23 新增，2026-10-24 代码落地）</a:t>
+              <a:t>027–031 数据后端迁移 · 轨迹 Tab · SSO 接收 · 本体数据权限 · 模型供应商发现（2026-10-13 ~ 10-18）；027 迁移已落地真库，030/031 已落部分代码；032–044 AgentOS 批次（10-23 新增，多数代码已落地，余 27 项收尾）</a:t>
             </a:r>
             <a:endParaRPr lang="zh-CN" sz="900">
               <a:solidFill>

</xml_diff>